<commit_message>
add resources; first draft of sensitivity analysis lecture
</commit_message>
<xml_diff>
--- a/resources/sds-workflow.pptx
+++ b/resources/sds-workflow.pptx
@@ -105,13 +105,18 @@
       </a:defRPr>
     </a:lvl9pPr>
   </p:defaultTextStyle>
+  <p:extLst>
+    <p:ext uri="{EFAFB233-063F-42B5-8137-9DF3F51BA10A}">
+      <p15:sldGuideLst xmlns:p15="http://schemas.microsoft.com/office/powerpoint/2012/main"/>
+    </p:ext>
+  </p:extLst>
 </p:presentation>
 </file>
 
 <file path=ppt/revisionInfo.xml><?xml version="1.0" encoding="utf-8"?>
 <p1510:revInfo xmlns:a="http://schemas.openxmlformats.org/drawingml/2006/main" xmlns:r="http://schemas.openxmlformats.org/officeDocument/2006/relationships" xmlns:p1510="http://schemas.microsoft.com/office/powerpoint/2015/10/main">
   <p1510:revLst>
-    <p1510:client id="{19714C2D-F468-4E25-A1D2-871A33A6A5D1}" v="3" dt="2026-08-10T12:48:26.792"/>
+    <p1510:client id="{19714C2D-F468-4E25-A1D2-871A33A6A5D1}" v="4" dt="2026-08-25T14:10:19.086"/>
   </p1510:revLst>
 </p1510:revInfo>
 </file>
@@ -121,17 +126,10 @@
   <pc:docChgLst>
     <pc:chgData name="Ben Matthews" userId="377ce8b0-c373-4490-aa17-52b4a43eb528" providerId="ADAL" clId="{39B4363D-8B87-459B-817C-111AE3B6D559}"/>
     <pc:docChg chg="undo custSel addSld delSld modSld">
-      <pc:chgData name="Ben Matthews" userId="377ce8b0-c373-4490-aa17-52b4a43eb528" providerId="ADAL" clId="{39B4363D-8B87-459B-817C-111AE3B6D559}" dt="2026-08-10T12:53:10.022" v="169" actId="207"/>
+      <pc:chgData name="Ben Matthews" userId="377ce8b0-c373-4490-aa17-52b4a43eb528" providerId="ADAL" clId="{39B4363D-8B87-459B-817C-111AE3B6D559}" dt="2026-08-25T14:10:49.877" v="192" actId="13926"/>
       <pc:docMkLst>
         <pc:docMk/>
       </pc:docMkLst>
-      <pc:sldChg chg="del">
-        <pc:chgData name="Ben Matthews" userId="377ce8b0-c373-4490-aa17-52b4a43eb528" providerId="ADAL" clId="{39B4363D-8B87-459B-817C-111AE3B6D559}" dt="2026-08-10T11:55:09.486" v="0" actId="47"/>
-        <pc:sldMkLst>
-          <pc:docMk/>
-          <pc:sldMk cId="812050190" sldId="256"/>
-        </pc:sldMkLst>
-      </pc:sldChg>
       <pc:sldChg chg="addSp delSp modSp mod">
         <pc:chgData name="Ben Matthews" userId="377ce8b0-c373-4490-aa17-52b4a43eb528" providerId="ADAL" clId="{39B4363D-8B87-459B-817C-111AE3B6D559}" dt="2026-08-10T12:52:48.687" v="153" actId="14100"/>
         <pc:sldMkLst>
@@ -154,14 +152,6 @@
             <ac:spMk id="70" creationId="{8F299E4F-E555-2517-4800-F03673192B3A}"/>
           </ac:spMkLst>
         </pc:spChg>
-        <pc:spChg chg="add del">
-          <ac:chgData name="Ben Matthews" userId="377ce8b0-c373-4490-aa17-52b4a43eb528" providerId="ADAL" clId="{39B4363D-8B87-459B-817C-111AE3B6D559}" dt="2026-08-10T11:57:50.266" v="27" actId="22"/>
-          <ac:spMkLst>
-            <pc:docMk/>
-            <pc:sldMk cId="4084633260" sldId="257"/>
-            <ac:spMk id="73" creationId="{B303942C-62C7-DA73-1167-4F767FBA3352}"/>
-          </ac:spMkLst>
-        </pc:spChg>
         <pc:cxnChg chg="mod">
           <ac:chgData name="Ben Matthews" userId="377ce8b0-c373-4490-aa17-52b4a43eb528" providerId="ADAL" clId="{39B4363D-8B87-459B-817C-111AE3B6D559}" dt="2026-08-10T11:57:45.497" v="25" actId="14100"/>
           <ac:cxnSpMkLst>
@@ -172,21 +162,21 @@
         </pc:cxnChg>
       </pc:sldChg>
       <pc:sldChg chg="addSp delSp modSp add mod">
-        <pc:chgData name="Ben Matthews" userId="377ce8b0-c373-4490-aa17-52b4a43eb528" providerId="ADAL" clId="{39B4363D-8B87-459B-817C-111AE3B6D559}" dt="2026-08-10T12:53:10.022" v="169" actId="207"/>
+        <pc:chgData name="Ben Matthews" userId="377ce8b0-c373-4490-aa17-52b4a43eb528" providerId="ADAL" clId="{39B4363D-8B87-459B-817C-111AE3B6D559}" dt="2026-08-25T14:10:49.877" v="192" actId="13926"/>
         <pc:sldMkLst>
           <pc:docMk/>
           <pc:sldMk cId="208834245" sldId="258"/>
         </pc:sldMkLst>
         <pc:spChg chg="add del mod">
-          <ac:chgData name="Ben Matthews" userId="377ce8b0-c373-4490-aa17-52b4a43eb528" providerId="ADAL" clId="{39B4363D-8B87-459B-817C-111AE3B6D559}" dt="2026-08-10T11:58:06.102" v="30" actId="478"/>
+          <ac:chgData name="Ben Matthews" userId="377ce8b0-c373-4490-aa17-52b4a43eb528" providerId="ADAL" clId="{39B4363D-8B87-459B-817C-111AE3B6D559}" dt="2026-08-25T14:10:19.979" v="173"/>
           <ac:spMkLst>
             <pc:docMk/>
             <pc:sldMk cId="208834245" sldId="258"/>
-            <ac:spMk id="2" creationId="{0B062233-5292-7D7C-DC97-95225066628F}"/>
+            <ac:spMk id="2" creationId="{19F7939B-55A1-0F1A-75C1-7E533A458F3B}"/>
           </ac:spMkLst>
         </pc:spChg>
         <pc:spChg chg="add mod">
-          <ac:chgData name="Ben Matthews" userId="377ce8b0-c373-4490-aa17-52b4a43eb528" providerId="ADAL" clId="{39B4363D-8B87-459B-817C-111AE3B6D559}" dt="2026-08-10T12:48:39.284" v="44" actId="1076"/>
+          <ac:chgData name="Ben Matthews" userId="377ce8b0-c373-4490-aa17-52b4a43eb528" providerId="ADAL" clId="{39B4363D-8B87-459B-817C-111AE3B6D559}" dt="2026-08-25T14:10:27.473" v="176" actId="207"/>
           <ac:spMkLst>
             <pc:docMk/>
             <pc:sldMk cId="208834245" sldId="258"/>
@@ -194,7 +184,7 @@
           </ac:spMkLst>
         </pc:spChg>
         <pc:spChg chg="mod">
-          <ac:chgData name="Ben Matthews" userId="377ce8b0-c373-4490-aa17-52b4a43eb528" providerId="ADAL" clId="{39B4363D-8B87-459B-817C-111AE3B6D559}" dt="2026-08-10T12:48:16.800" v="33" actId="207"/>
+          <ac:chgData name="Ben Matthews" userId="377ce8b0-c373-4490-aa17-52b4a43eb528" providerId="ADAL" clId="{39B4363D-8B87-459B-817C-111AE3B6D559}" dt="2026-08-25T14:10:24.627" v="175" actId="207"/>
           <ac:spMkLst>
             <pc:docMk/>
             <pc:sldMk cId="208834245" sldId="258"/>
@@ -210,7 +200,7 @@
           </ac:spMkLst>
         </pc:spChg>
         <pc:spChg chg="add mod">
-          <ac:chgData name="Ben Matthews" userId="377ce8b0-c373-4490-aa17-52b4a43eb528" providerId="ADAL" clId="{39B4363D-8B87-459B-817C-111AE3B6D559}" dt="2026-08-10T12:51:18.369" v="135" actId="1076"/>
+          <ac:chgData name="Ben Matthews" userId="377ce8b0-c373-4490-aa17-52b4a43eb528" providerId="ADAL" clId="{39B4363D-8B87-459B-817C-111AE3B6D559}" dt="2026-08-25T14:10:30.496" v="178" actId="13926"/>
           <ac:spMkLst>
             <pc:docMk/>
             <pc:sldMk cId="208834245" sldId="258"/>
@@ -218,7 +208,7 @@
           </ac:spMkLst>
         </pc:spChg>
         <pc:spChg chg="add mod">
-          <ac:chgData name="Ben Matthews" userId="377ce8b0-c373-4490-aa17-52b4a43eb528" providerId="ADAL" clId="{39B4363D-8B87-459B-817C-111AE3B6D559}" dt="2026-08-10T12:49:19.057" v="66" actId="14100"/>
+          <ac:chgData name="Ben Matthews" userId="377ce8b0-c373-4490-aa17-52b4a43eb528" providerId="ADAL" clId="{39B4363D-8B87-459B-817C-111AE3B6D559}" dt="2026-08-25T14:10:40.580" v="186" actId="13926"/>
           <ac:spMkLst>
             <pc:docMk/>
             <pc:sldMk cId="208834245" sldId="258"/>
@@ -242,7 +232,7 @@
           </ac:spMkLst>
         </pc:spChg>
         <pc:spChg chg="add mod">
-          <ac:chgData name="Ben Matthews" userId="377ce8b0-c373-4490-aa17-52b4a43eb528" providerId="ADAL" clId="{39B4363D-8B87-459B-817C-111AE3B6D559}" dt="2026-08-10T12:51:09.876" v="124" actId="1076"/>
+          <ac:chgData name="Ben Matthews" userId="377ce8b0-c373-4490-aa17-52b4a43eb528" providerId="ADAL" clId="{39B4363D-8B87-459B-817C-111AE3B6D559}" dt="2026-08-25T14:10:43.388" v="188" actId="13926"/>
           <ac:spMkLst>
             <pc:docMk/>
             <pc:sldMk cId="208834245" sldId="258"/>
@@ -258,7 +248,7 @@
           </ac:spMkLst>
         </pc:spChg>
         <pc:spChg chg="add mod">
-          <ac:chgData name="Ben Matthews" userId="377ce8b0-c373-4490-aa17-52b4a43eb528" providerId="ADAL" clId="{39B4363D-8B87-459B-817C-111AE3B6D559}" dt="2026-08-10T12:49:45.336" v="85" actId="20577"/>
+          <ac:chgData name="Ben Matthews" userId="377ce8b0-c373-4490-aa17-52b4a43eb528" providerId="ADAL" clId="{39B4363D-8B87-459B-817C-111AE3B6D559}" dt="2026-08-25T14:10:32.858" v="180" actId="13926"/>
           <ac:spMkLst>
             <pc:docMk/>
             <pc:sldMk cId="208834245" sldId="258"/>
@@ -274,7 +264,7 @@
           </ac:spMkLst>
         </pc:spChg>
         <pc:spChg chg="add mod">
-          <ac:chgData name="Ben Matthews" userId="377ce8b0-c373-4490-aa17-52b4a43eb528" providerId="ADAL" clId="{39B4363D-8B87-459B-817C-111AE3B6D559}" dt="2026-08-10T12:49:51.932" v="87" actId="1076"/>
+          <ac:chgData name="Ben Matthews" userId="377ce8b0-c373-4490-aa17-52b4a43eb528" providerId="ADAL" clId="{39B4363D-8B87-459B-817C-111AE3B6D559}" dt="2026-08-25T14:10:35.056" v="182" actId="13926"/>
           <ac:spMkLst>
             <pc:docMk/>
             <pc:sldMk cId="208834245" sldId="258"/>
@@ -290,7 +280,7 @@
           </ac:spMkLst>
         </pc:spChg>
         <pc:spChg chg="add mod">
-          <ac:chgData name="Ben Matthews" userId="377ce8b0-c373-4490-aa17-52b4a43eb528" providerId="ADAL" clId="{39B4363D-8B87-459B-817C-111AE3B6D559}" dt="2026-08-10T12:49:57.582" v="89" actId="1076"/>
+          <ac:chgData name="Ben Matthews" userId="377ce8b0-c373-4490-aa17-52b4a43eb528" providerId="ADAL" clId="{39B4363D-8B87-459B-817C-111AE3B6D559}" dt="2026-08-25T14:10:37.654" v="184" actId="13926"/>
           <ac:spMkLst>
             <pc:docMk/>
             <pc:sldMk cId="208834245" sldId="258"/>
@@ -298,7 +288,7 @@
           </ac:spMkLst>
         </pc:spChg>
         <pc:spChg chg="mod">
-          <ac:chgData name="Ben Matthews" userId="377ce8b0-c373-4490-aa17-52b4a43eb528" providerId="ADAL" clId="{39B4363D-8B87-459B-817C-111AE3B6D559}" dt="2026-08-10T12:48:16.800" v="33" actId="207"/>
+          <ac:chgData name="Ben Matthews" userId="377ce8b0-c373-4490-aa17-52b4a43eb528" providerId="ADAL" clId="{39B4363D-8B87-459B-817C-111AE3B6D559}" dt="2026-08-25T14:10:24.627" v="175" actId="207"/>
           <ac:spMkLst>
             <pc:docMk/>
             <pc:sldMk cId="208834245" sldId="258"/>
@@ -306,7 +296,7 @@
           </ac:spMkLst>
         </pc:spChg>
         <pc:spChg chg="add mod">
-          <ac:chgData name="Ben Matthews" userId="377ce8b0-c373-4490-aa17-52b4a43eb528" providerId="ADAL" clId="{39B4363D-8B87-459B-817C-111AE3B6D559}" dt="2026-08-10T12:50:10.192" v="101" actId="20577"/>
+          <ac:chgData name="Ben Matthews" userId="377ce8b0-c373-4490-aa17-52b4a43eb528" providerId="ADAL" clId="{39B4363D-8B87-459B-817C-111AE3B6D559}" dt="2026-08-25T14:10:49.877" v="192" actId="13926"/>
           <ac:spMkLst>
             <pc:docMk/>
             <pc:sldMk cId="208834245" sldId="258"/>
@@ -314,7 +304,7 @@
           </ac:spMkLst>
         </pc:spChg>
         <pc:spChg chg="add mod">
-          <ac:chgData name="Ben Matthews" userId="377ce8b0-c373-4490-aa17-52b4a43eb528" providerId="ADAL" clId="{39B4363D-8B87-459B-817C-111AE3B6D559}" dt="2026-08-10T12:50:25.385" v="106" actId="20577"/>
+          <ac:chgData name="Ben Matthews" userId="377ce8b0-c373-4490-aa17-52b4a43eb528" providerId="ADAL" clId="{39B4363D-8B87-459B-817C-111AE3B6D559}" dt="2026-08-25T14:10:46.579" v="190" actId="13926"/>
           <ac:spMkLst>
             <pc:docMk/>
             <pc:sldMk cId="208834245" sldId="258"/>
@@ -330,6 +320,14 @@
           </ac:spMkLst>
         </pc:spChg>
         <pc:spChg chg="mod">
+          <ac:chgData name="Ben Matthews" userId="377ce8b0-c373-4490-aa17-52b4a43eb528" providerId="ADAL" clId="{39B4363D-8B87-459B-817C-111AE3B6D559}" dt="2026-08-25T14:10:24.627" v="175" actId="207"/>
+          <ac:spMkLst>
+            <pc:docMk/>
+            <pc:sldMk cId="208834245" sldId="258"/>
+            <ac:spMk id="45" creationId="{830891D4-6C32-56D4-105E-6EE7603EE3AA}"/>
+          </ac:spMkLst>
+        </pc:spChg>
+        <pc:spChg chg="mod">
           <ac:chgData name="Ben Matthews" userId="377ce8b0-c373-4490-aa17-52b4a43eb528" providerId="ADAL" clId="{39B4363D-8B87-459B-817C-111AE3B6D559}" dt="2026-08-10T12:48:16.800" v="33" actId="207"/>
           <ac:spMkLst>
             <pc:docMk/>
@@ -338,7 +336,7 @@
           </ac:spMkLst>
         </pc:spChg>
         <pc:spChg chg="mod">
-          <ac:chgData name="Ben Matthews" userId="377ce8b0-c373-4490-aa17-52b4a43eb528" providerId="ADAL" clId="{39B4363D-8B87-459B-817C-111AE3B6D559}" dt="2026-08-10T12:48:16.800" v="33" actId="207"/>
+          <ac:chgData name="Ben Matthews" userId="377ce8b0-c373-4490-aa17-52b4a43eb528" providerId="ADAL" clId="{39B4363D-8B87-459B-817C-111AE3B6D559}" dt="2026-08-25T14:10:24.627" v="175" actId="207"/>
           <ac:spMkLst>
             <pc:docMk/>
             <pc:sldMk cId="208834245" sldId="258"/>
@@ -351,14 +349,6 @@
             <pc:docMk/>
             <pc:sldMk cId="208834245" sldId="258"/>
             <ac:spMk id="68" creationId="{94F0DBF6-B529-4947-DDA6-F17FC9BDB064}"/>
-          </ac:spMkLst>
-        </pc:spChg>
-        <pc:spChg chg="del mod">
-          <ac:chgData name="Ben Matthews" userId="377ce8b0-c373-4490-aa17-52b4a43eb528" providerId="ADAL" clId="{39B4363D-8B87-459B-817C-111AE3B6D559}" dt="2026-08-10T12:52:59.216" v="166" actId="478"/>
-          <ac:spMkLst>
-            <pc:docMk/>
-            <pc:sldMk cId="208834245" sldId="258"/>
-            <ac:spMk id="70" creationId="{FA7BF823-465D-7A57-DA74-D67E2A748580}"/>
           </ac:spMkLst>
         </pc:spChg>
       </pc:sldChg>
@@ -514,7 +504,7 @@
           <a:p>
             <a:fld id="{B22F8215-837C-4C71-9C8F-9FD3708D1125}" type="datetimeFigureOut">
               <a:rPr lang="en-GB" smtClean="0"/>
-              <a:t>10/08/2026</a:t>
+              <a:t>25/08/2026</a:t>
             </a:fld>
             <a:endParaRPr lang="en-GB"/>
           </a:p>
@@ -712,7 +702,7 @@
           <a:p>
             <a:fld id="{B22F8215-837C-4C71-9C8F-9FD3708D1125}" type="datetimeFigureOut">
               <a:rPr lang="en-GB" smtClean="0"/>
-              <a:t>10/08/2026</a:t>
+              <a:t>25/08/2026</a:t>
             </a:fld>
             <a:endParaRPr lang="en-GB"/>
           </a:p>
@@ -920,7 +910,7 @@
           <a:p>
             <a:fld id="{B22F8215-837C-4C71-9C8F-9FD3708D1125}" type="datetimeFigureOut">
               <a:rPr lang="en-GB" smtClean="0"/>
-              <a:t>10/08/2026</a:t>
+              <a:t>25/08/2026</a:t>
             </a:fld>
             <a:endParaRPr lang="en-GB"/>
           </a:p>
@@ -1118,7 +1108,7 @@
           <a:p>
             <a:fld id="{B22F8215-837C-4C71-9C8F-9FD3708D1125}" type="datetimeFigureOut">
               <a:rPr lang="en-GB" smtClean="0"/>
-              <a:t>10/08/2026</a:t>
+              <a:t>25/08/2026</a:t>
             </a:fld>
             <a:endParaRPr lang="en-GB"/>
           </a:p>
@@ -1393,7 +1383,7 @@
           <a:p>
             <a:fld id="{B22F8215-837C-4C71-9C8F-9FD3708D1125}" type="datetimeFigureOut">
               <a:rPr lang="en-GB" smtClean="0"/>
-              <a:t>10/08/2026</a:t>
+              <a:t>25/08/2026</a:t>
             </a:fld>
             <a:endParaRPr lang="en-GB"/>
           </a:p>
@@ -1658,7 +1648,7 @@
           <a:p>
             <a:fld id="{B22F8215-837C-4C71-9C8F-9FD3708D1125}" type="datetimeFigureOut">
               <a:rPr lang="en-GB" smtClean="0"/>
-              <a:t>10/08/2026</a:t>
+              <a:t>25/08/2026</a:t>
             </a:fld>
             <a:endParaRPr lang="en-GB"/>
           </a:p>
@@ -2070,7 +2060,7 @@
           <a:p>
             <a:fld id="{B22F8215-837C-4C71-9C8F-9FD3708D1125}" type="datetimeFigureOut">
               <a:rPr lang="en-GB" smtClean="0"/>
-              <a:t>10/08/2026</a:t>
+              <a:t>25/08/2026</a:t>
             </a:fld>
             <a:endParaRPr lang="en-GB"/>
           </a:p>
@@ -2211,7 +2201,7 @@
           <a:p>
             <a:fld id="{B22F8215-837C-4C71-9C8F-9FD3708D1125}" type="datetimeFigureOut">
               <a:rPr lang="en-GB" smtClean="0"/>
-              <a:t>10/08/2026</a:t>
+              <a:t>25/08/2026</a:t>
             </a:fld>
             <a:endParaRPr lang="en-GB"/>
           </a:p>
@@ -2324,7 +2314,7 @@
           <a:p>
             <a:fld id="{B22F8215-837C-4C71-9C8F-9FD3708D1125}" type="datetimeFigureOut">
               <a:rPr lang="en-GB" smtClean="0"/>
-              <a:t>10/08/2026</a:t>
+              <a:t>25/08/2026</a:t>
             </a:fld>
             <a:endParaRPr lang="en-GB"/>
           </a:p>
@@ -2635,7 +2625,7 @@
           <a:p>
             <a:fld id="{B22F8215-837C-4C71-9C8F-9FD3708D1125}" type="datetimeFigureOut">
               <a:rPr lang="en-GB" smtClean="0"/>
-              <a:t>10/08/2026</a:t>
+              <a:t>25/08/2026</a:t>
             </a:fld>
             <a:endParaRPr lang="en-GB"/>
           </a:p>
@@ -2923,7 +2913,7 @@
           <a:p>
             <a:fld id="{B22F8215-837C-4C71-9C8F-9FD3708D1125}" type="datetimeFigureOut">
               <a:rPr lang="en-GB" smtClean="0"/>
-              <a:t>10/08/2026</a:t>
+              <a:t>25/08/2026</a:t>
             </a:fld>
             <a:endParaRPr lang="en-GB"/>
           </a:p>
@@ -3164,7 +3154,7 @@
           <a:p>
             <a:fld id="{B22F8215-837C-4C71-9C8F-9FD3708D1125}" type="datetimeFigureOut">
               <a:rPr lang="en-GB" smtClean="0"/>
-              <a:t>10/08/2026</a:t>
+              <a:t>25/08/2026</a:t>
             </a:fld>
             <a:endParaRPr lang="en-GB"/>
           </a:p>
@@ -6600,9 +6590,9 @@
           <a:p>
             <a:r>
               <a:rPr lang="en-GB" dirty="0">
-                <a:solidFill>
-                  <a:schemeClr val="accent3"/>
-                </a:solidFill>
+                <a:highlight>
+                  <a:srgbClr val="FFFF00"/>
+                </a:highlight>
               </a:rPr>
               <a:t>Unit One</a:t>
             </a:r>
@@ -6639,9 +6629,9 @@
           <a:p>
             <a:r>
               <a:rPr lang="en-GB" dirty="0">
-                <a:solidFill>
-                  <a:schemeClr val="accent3"/>
-                </a:solidFill>
+                <a:highlight>
+                  <a:srgbClr val="FFFF00"/>
+                </a:highlight>
               </a:rPr>
               <a:t>Unit One and Eight</a:t>
             </a:r>
@@ -6678,9 +6668,9 @@
           <a:p>
             <a:r>
               <a:rPr lang="en-GB" dirty="0">
-                <a:solidFill>
-                  <a:schemeClr val="accent3"/>
-                </a:solidFill>
+                <a:highlight>
+                  <a:srgbClr val="FFFF00"/>
+                </a:highlight>
               </a:rPr>
               <a:t>Units Two and Three</a:t>
             </a:r>
@@ -6717,9 +6707,9 @@
           <a:p>
             <a:r>
               <a:rPr lang="en-GB" dirty="0">
-                <a:solidFill>
-                  <a:schemeClr val="accent3"/>
-                </a:solidFill>
+                <a:highlight>
+                  <a:srgbClr val="FFFF00"/>
+                </a:highlight>
               </a:rPr>
               <a:t>Units Two and Three, Seven and Eight</a:t>
             </a:r>
@@ -6756,9 +6746,9 @@
           <a:p>
             <a:r>
               <a:rPr lang="en-GB" dirty="0">
-                <a:solidFill>
-                  <a:schemeClr val="accent3"/>
-                </a:solidFill>
+                <a:highlight>
+                  <a:srgbClr val="FFFF00"/>
+                </a:highlight>
               </a:rPr>
               <a:t>Unit Four</a:t>
             </a:r>
@@ -6795,9 +6785,9 @@
           <a:p>
             <a:r>
               <a:rPr lang="en-GB" dirty="0">
-                <a:solidFill>
-                  <a:schemeClr val="accent3"/>
-                </a:solidFill>
+                <a:highlight>
+                  <a:srgbClr val="FFFF00"/>
+                </a:highlight>
               </a:rPr>
               <a:t>Unit Four</a:t>
             </a:r>
@@ -6834,9 +6824,9 @@
           <a:p>
             <a:r>
               <a:rPr lang="en-GB" dirty="0">
-                <a:solidFill>
-                  <a:schemeClr val="accent3"/>
-                </a:solidFill>
+                <a:highlight>
+                  <a:srgbClr val="FFFF00"/>
+                </a:highlight>
               </a:rPr>
               <a:t>Unit Four</a:t>
             </a:r>
@@ -6873,9 +6863,9 @@
           <a:p>
             <a:r>
               <a:rPr lang="en-GB" dirty="0">
-                <a:solidFill>
-                  <a:schemeClr val="accent3"/>
-                </a:solidFill>
+                <a:highlight>
+                  <a:srgbClr val="FFFF00"/>
+                </a:highlight>
               </a:rPr>
               <a:t>Units Four and Five</a:t>
             </a:r>
@@ -6912,9 +6902,9 @@
           <a:p>
             <a:r>
               <a:rPr lang="en-GB" dirty="0">
-                <a:solidFill>
-                  <a:schemeClr val="accent3"/>
-                </a:solidFill>
+                <a:highlight>
+                  <a:srgbClr val="FFFF00"/>
+                </a:highlight>
               </a:rPr>
               <a:t>Unit Six</a:t>
             </a:r>

</xml_diff>